<commit_message>
change presentations a bit
</commit_message>
<xml_diff>
--- a/first_part/pres/w04/Grafovi II.pptx
+++ b/first_part/pres/w04/Grafovi II.pptx
@@ -12253,7 +12253,7 @@
       </p:sp>
       <p:sp>
         <p:nvSpPr>
-          <p:cNvPr id="395" name="Kompleksnost:…"/>
+          <p:cNvPr id="395" name="Kompleksnost:"/>
           <p:cNvSpPr txBox="1"/>
           <p:nvPr/>
         </p:nvSpPr>
@@ -12278,9 +12278,8 @@
           <a:bodyPr lIns="50800" tIns="50800" rIns="50800" bIns="50800">
             <a:normAutofit fontScale="100000" lnSpcReduction="0"/>
           </a:bodyPr>
-          <a:lstStyle/>
-          <a:p>
-            <a:pPr marL="609600" indent="-609600" defTabSz="825500">
+          <a:lstStyle>
+            <a:lvl1pPr marL="609600" indent="-609600" defTabSz="825500">
               <a:lnSpc>
                 <a:spcPct val="100000"/>
               </a:lnSpc>
@@ -12302,13 +12301,8 @@
                 <a:cs typeface="+mn-cs"/>
                 <a:sym typeface="Montserrat Thin Bold"/>
               </a:defRPr>
-            </a:pPr>
-            <a:r>
-              <a:t>Kompleksnost:</a:t>
-            </a:r>
-          </a:p>
-          <a:p>
-            <a:pPr lvl="1" marL="1117600" indent="-381000">
+            </a:lvl1pPr>
+            <a:lvl2pPr marL="1117600" indent="-381000">
               <a:buClr>
                 <a:schemeClr val="accent6">
                   <a:hueOff val="13513096"/>
@@ -12318,208 +12312,105 @@
               </a:buClr>
               <a:buSzPct val="123000"/>
               <a:buChar char="⏵"/>
-            </a:pPr>
-            <a:r>
-              <a:t>Ako se koriti </a:t>
-            </a:r>
-            <a:r>
-              <a:rPr>
-                <a:latin typeface="+mn-lt"/>
-                <a:ea typeface="+mn-ea"/>
-                <a:cs typeface="+mn-cs"/>
-                <a:sym typeface="Montserrat Thin Bold"/>
-              </a:rPr>
-              <a:t>matrica susedsva</a:t>
-            </a:r>
-            <a:r>
-              <a:t>: </a:t>
-            </a:r>
+            </a:lvl2pPr>
+          </a:lstStyle>
+          <a:p>
+            <a:pPr/>
+            <a:r>
+              <a:t>Kompleksnost:</a:t>
+            </a:r>
+          </a:p>
+          <a:p>
+            <a:pPr lvl="1"/>
             <a14:m>
-              <m:oMath>
-                <m:r>
-                  <a:rPr xmlns:a="http://schemas.openxmlformats.org/drawingml/2006/main" sz="3650" i="1">
-                    <a:solidFill>
-                      <a:srgbClr val="000000"/>
-                    </a:solidFill>
-                    <a:latin typeface="Cambria Math" panose="02040503050406030204" pitchFamily="18" charset="0"/>
-                  </a:rPr>
-                  <m:t>O</m:t>
-                </m:r>
-                <m:r>
-                  <a:rPr xmlns:a="http://schemas.openxmlformats.org/drawingml/2006/main" sz="3650" i="1">
-                    <a:solidFill>
-                      <a:srgbClr val="000000"/>
-                    </a:solidFill>
-                    <a:latin typeface="Cambria Math" panose="02040503050406030204" pitchFamily="18" charset="0"/>
-                  </a:rPr>
-                  <m:t>(</m:t>
-                </m:r>
-                <m:sSup>
-                  <m:e>
-                    <m:r>
-                      <a:rPr xmlns:a="http://schemas.openxmlformats.org/drawingml/2006/main" sz="3650" i="1">
-                        <a:solidFill>
-                          <a:srgbClr val="000000"/>
-                        </a:solidFill>
-                        <a:latin typeface="Cambria Math" panose="02040503050406030204" pitchFamily="18" charset="0"/>
-                      </a:rPr>
-                      <m:t>V</m:t>
-                    </m:r>
-                  </m:e>
-                  <m:sup>
-                    <m:r>
-                      <a:rPr xmlns:a="http://schemas.openxmlformats.org/drawingml/2006/main" sz="3650" i="1">
-                        <a:solidFill>
-                          <a:srgbClr val="000000"/>
-                        </a:solidFill>
-                        <a:latin typeface="Cambria Math" panose="02040503050406030204" pitchFamily="18" charset="0"/>
-                      </a:rPr>
-                      <m:t>2</m:t>
-                    </m:r>
-                  </m:sup>
-                </m:sSup>
-                <m:r>
-                  <a:rPr xmlns:a="http://schemas.openxmlformats.org/drawingml/2006/main" sz="3650" i="1">
-                    <a:solidFill>
-                      <a:srgbClr val="000000"/>
-                    </a:solidFill>
-                    <a:latin typeface="Cambria Math" panose="02040503050406030204" pitchFamily="18" charset="0"/>
-                  </a:rPr>
-                  <m:t>)</m:t>
-                </m:r>
-              </m:oMath>
-            </a14:m>
-          </a:p>
-          <a:p>
-            <a:pPr lvl="1" marL="1117600" indent="-381000">
-              <a:buClr>
-                <a:schemeClr val="accent6">
-                  <a:hueOff val="13513096"/>
-                  <a:satOff val="-92324"/>
-                  <a:lumOff val="-42615"/>
-                </a:schemeClr>
-              </a:buClr>
-              <a:buSzPct val="123000"/>
-              <a:buChar char="⏵"/>
-            </a:pPr>
-            <a:r>
-              <a:t>Ako se koristi </a:t>
-            </a:r>
-            <a:r>
-              <a:rPr>
-                <a:latin typeface="+mn-lt"/>
-                <a:ea typeface="+mn-ea"/>
-                <a:cs typeface="+mn-cs"/>
-                <a:sym typeface="Montserrat Thin Bold"/>
-              </a:rPr>
-              <a:t>lista susedstva</a:t>
-            </a:r>
-            <a:r>
-              <a:t> i </a:t>
-            </a:r>
-            <a:r>
-              <a:rPr>
-                <a:latin typeface="+mn-lt"/>
-                <a:ea typeface="+mn-ea"/>
-                <a:cs typeface="+mn-cs"/>
-                <a:sym typeface="Montserrat Thin Bold"/>
-              </a:rPr>
-              <a:t>prioritetni red</a:t>
-            </a:r>
-            <a:r>
-              <a:t> (npr. m</a:t>
-            </a:r>
-            <a:r>
-              <a:rPr i="1"/>
-              <a:t>in-heap</a:t>
-            </a:r>
-            <a:r>
-              <a:t>): </a:t>
-            </a:r>
-            <a14:m>
-              <m:oMath>
-                <m:r>
-                  <a:rPr xmlns:a="http://schemas.openxmlformats.org/drawingml/2006/main" sz="3650" i="1">
-                    <a:solidFill>
-                      <a:srgbClr val="000000"/>
-                    </a:solidFill>
-                    <a:latin typeface="Cambria Math" panose="02040503050406030204" pitchFamily="18" charset="0"/>
-                  </a:rPr>
-                  <m:t>O</m:t>
-                </m:r>
-                <m:r>
-                  <a:rPr xmlns:a="http://schemas.openxmlformats.org/drawingml/2006/main" sz="3650" i="1">
-                    <a:solidFill>
-                      <a:srgbClr val="000000"/>
-                    </a:solidFill>
-                    <a:latin typeface="Cambria Math" panose="02040503050406030204" pitchFamily="18" charset="0"/>
-                  </a:rPr>
-                  <m:t>(</m:t>
-                </m:r>
-                <m:r>
-                  <a:rPr xmlns:a="http://schemas.openxmlformats.org/drawingml/2006/main" sz="3650" i="1">
-                    <a:solidFill>
-                      <a:srgbClr val="000000"/>
-                    </a:solidFill>
-                    <a:latin typeface="Cambria Math" panose="02040503050406030204" pitchFamily="18" charset="0"/>
-                  </a:rPr>
-                  <m:t>V</m:t>
-                </m:r>
-                <m:r>
-                  <a:rPr xmlns:a="http://schemas.openxmlformats.org/drawingml/2006/main" sz="3650" i="1">
-                    <a:solidFill>
-                      <a:srgbClr val="000000"/>
-                    </a:solidFill>
-                    <a:latin typeface="Cambria Math" panose="02040503050406030204" pitchFamily="18" charset="0"/>
-                  </a:rPr>
-                  <m:t>⋅</m:t>
-                </m:r>
-                <m:r>
-                  <a:rPr xmlns:a="http://schemas.openxmlformats.org/drawingml/2006/main" sz="3650" i="1">
-                    <a:solidFill>
-                      <a:srgbClr val="000000"/>
-                    </a:solidFill>
-                    <a:latin typeface="Cambria Math" panose="02040503050406030204" pitchFamily="18" charset="0"/>
-                  </a:rPr>
-                  <m:t>l</m:t>
-                </m:r>
-                <m:r>
-                  <a:rPr xmlns:a="http://schemas.openxmlformats.org/drawingml/2006/main" sz="3650" i="1">
-                    <a:solidFill>
-                      <a:srgbClr val="000000"/>
-                    </a:solidFill>
-                    <a:latin typeface="Cambria Math" panose="02040503050406030204" pitchFamily="18" charset="0"/>
-                  </a:rPr>
-                  <m:t>o</m:t>
-                </m:r>
-                <m:r>
-                  <a:rPr xmlns:a="http://schemas.openxmlformats.org/drawingml/2006/main" sz="3650" i="1">
-                    <a:solidFill>
-                      <a:srgbClr val="000000"/>
-                    </a:solidFill>
-                    <a:latin typeface="Cambria Math" panose="02040503050406030204" pitchFamily="18" charset="0"/>
-                  </a:rPr>
-                  <m:t>g</m:t>
-                </m:r>
-                <m:r>
-                  <a:rPr xmlns:a="http://schemas.openxmlformats.org/drawingml/2006/main" sz="3650" i="1">
-                    <a:solidFill>
-                      <a:srgbClr val="000000"/>
-                    </a:solidFill>
-                    <a:latin typeface="Cambria Math" panose="02040503050406030204" pitchFamily="18" charset="0"/>
-                  </a:rPr>
-                  <m:t>V</m:t>
-                </m:r>
-                <m:r>
-                  <a:rPr xmlns:a="http://schemas.openxmlformats.org/drawingml/2006/main" sz="3650" i="1">
-                    <a:solidFill>
-                      <a:srgbClr val="000000"/>
-                    </a:solidFill>
-                    <a:latin typeface="Cambria Math" panose="02040503050406030204" pitchFamily="18" charset="0"/>
-                  </a:rPr>
-                  <m:t>)</m:t>
-                </m:r>
-              </m:oMath>
+              <m:oMathPara>
+                <m:oMathParaPr>
+                  <m:jc m:val="left"/>
+                </m:oMathParaPr>
+                <m:oMath>
+                  <m:r>
+                    <a:rPr xmlns:a="http://schemas.openxmlformats.org/drawingml/2006/main" sz="3650" i="1">
+                      <a:solidFill>
+                        <a:srgbClr val="000000"/>
+                      </a:solidFill>
+                      <a:latin typeface="Cambria Math" panose="02040503050406030204" pitchFamily="18" charset="0"/>
+                    </a:rPr>
+                    <m:t>O</m:t>
+                  </m:r>
+                  <m:r>
+                    <a:rPr xmlns:a="http://schemas.openxmlformats.org/drawingml/2006/main" sz="3650" i="1">
+                      <a:solidFill>
+                        <a:srgbClr val="000000"/>
+                      </a:solidFill>
+                      <a:latin typeface="Cambria Math" panose="02040503050406030204" pitchFamily="18" charset="0"/>
+                    </a:rPr>
+                    <m:t>(</m:t>
+                  </m:r>
+                  <m:r>
+                    <a:rPr xmlns:a="http://schemas.openxmlformats.org/drawingml/2006/main" sz="3650" i="1">
+                      <a:solidFill>
+                        <a:srgbClr val="000000"/>
+                      </a:solidFill>
+                      <a:latin typeface="Cambria Math" panose="02040503050406030204" pitchFamily="18" charset="0"/>
+                    </a:rPr>
+                    <m:t>E</m:t>
+                  </m:r>
+                  <m:r>
+                    <a:rPr xmlns:a="http://schemas.openxmlformats.org/drawingml/2006/main" sz="3650" i="1">
+                      <a:solidFill>
+                        <a:srgbClr val="000000"/>
+                      </a:solidFill>
+                      <a:latin typeface="Cambria Math" panose="02040503050406030204" pitchFamily="18" charset="0"/>
+                    </a:rPr>
+                    <m:t>⋅</m:t>
+                  </m:r>
+                  <m:r>
+                    <a:rPr xmlns:a="http://schemas.openxmlformats.org/drawingml/2006/main" sz="3650" i="1">
+                      <a:solidFill>
+                        <a:srgbClr val="000000"/>
+                      </a:solidFill>
+                      <a:latin typeface="Cambria Math" panose="02040503050406030204" pitchFamily="18" charset="0"/>
+                    </a:rPr>
+                    <m:t>l</m:t>
+                  </m:r>
+                  <m:r>
+                    <a:rPr xmlns:a="http://schemas.openxmlformats.org/drawingml/2006/main" sz="3650" i="1">
+                      <a:solidFill>
+                        <a:srgbClr val="000000"/>
+                      </a:solidFill>
+                      <a:latin typeface="Cambria Math" panose="02040503050406030204" pitchFamily="18" charset="0"/>
+                    </a:rPr>
+                    <m:t>o</m:t>
+                  </m:r>
+                  <m:r>
+                    <a:rPr xmlns:a="http://schemas.openxmlformats.org/drawingml/2006/main" sz="3650" i="1">
+                      <a:solidFill>
+                        <a:srgbClr val="000000"/>
+                      </a:solidFill>
+                      <a:latin typeface="Cambria Math" panose="02040503050406030204" pitchFamily="18" charset="0"/>
+                    </a:rPr>
+                    <m:t>g</m:t>
+                  </m:r>
+                  <m:r>
+                    <a:rPr xmlns:a="http://schemas.openxmlformats.org/drawingml/2006/main" sz="3650" i="1">
+                      <a:solidFill>
+                        <a:srgbClr val="000000"/>
+                      </a:solidFill>
+                      <a:latin typeface="Cambria Math" panose="02040503050406030204" pitchFamily="18" charset="0"/>
+                    </a:rPr>
+                    <m:t>E</m:t>
+                  </m:r>
+                  <m:r>
+                    <a:rPr xmlns:a="http://schemas.openxmlformats.org/drawingml/2006/main" sz="3650" i="1">
+                      <a:solidFill>
+                        <a:srgbClr val="000000"/>
+                      </a:solidFill>
+                      <a:latin typeface="Cambria Math" panose="02040503050406030204" pitchFamily="18" charset="0"/>
+                    </a:rPr>
+                    <m:t>)</m:t>
+                  </m:r>
+                </m:oMath>
+              </m:oMathPara>
             </a14:m>
           </a:p>
         </p:txBody>
@@ -13107,54 +12998,6 @@
                       </p:childTnLst>
                     </p:cTn>
                   </p:par>
-                  <p:par>
-                    <p:cTn id="48" fill="hold">
-                      <p:stCondLst>
-                        <p:cond delay="indefinite"/>
-                      </p:stCondLst>
-                      <p:childTnLst>
-                        <p:par>
-                          <p:cTn id="49" fill="hold">
-                            <p:stCondLst>
-                              <p:cond delay="0"/>
-                            </p:stCondLst>
-                            <p:childTnLst>
-                              <p:par>
-                                <p:cTn id="50" presetClass="entr" nodeType="clickEffect" presetSubtype="0" presetID="1" grpId="3" fill="hold">
-                                  <p:stCondLst>
-                                    <p:cond delay="0"/>
-                                  </p:stCondLst>
-                                  <p:iterate type="el" backwards="0">
-                                    <p:tmAbs val="0"/>
-                                  </p:iterate>
-                                  <p:childTnLst>
-                                    <p:set>
-                                      <p:cBhvr>
-                                        <p:cTn id="51" fill="hold"/>
-                                        <p:tgtEl>
-                                          <p:spTgt spid="395">
-                                            <p:txEl>
-                                              <p:pRg st="2" end="2"/>
-                                            </p:txEl>
-                                          </p:spTgt>
-                                        </p:tgtEl>
-                                        <p:attrNameLst>
-                                          <p:attrName>style.visibility</p:attrName>
-                                        </p:attrNameLst>
-                                      </p:cBhvr>
-                                      <p:to>
-                                        <p:strVal val="visible"/>
-                                      </p:to>
-                                    </p:set>
-                                  </p:childTnLst>
-                                </p:cTn>
-                              </p:par>
-                            </p:childTnLst>
-                          </p:cTn>
-                        </p:par>
-                      </p:childTnLst>
-                    </p:cTn>
-                  </p:par>
                 </p:childTnLst>
               </p:cTn>
               <p:prevCondLst>
@@ -13177,8 +13020,8 @@
       </p:par>
     </p:tnLst>
     <p:bldLst>
+      <p:bldP build="whole" bldLvl="1" animBg="1" rev="0" advAuto="0" spid="392" grpId="2"/>
       <p:bldP build="p" bldLvl="5" animBg="1" rev="0" advAuto="0" spid="394" grpId="1"/>
-      <p:bldP build="whole" bldLvl="1" animBg="1" rev="0" advAuto="0" spid="392" grpId="2"/>
       <p:bldP build="p" bldLvl="5" animBg="1" rev="0" advAuto="0" spid="395" grpId="3"/>
     </p:bldLst>
   </p:timing>
@@ -13583,8 +13426,8 @@
       </p:par>
     </p:tnLst>
     <p:bldLst>
+      <p:bldP build="p" bldLvl="5" animBg="1" rev="0" advAuto="0" spid="398" grpId="1"/>
       <p:bldP build="whole" bldLvl="1" animBg="1" rev="0" advAuto="0" spid="399" grpId="2"/>
-      <p:bldP build="p" bldLvl="5" animBg="1" rev="0" advAuto="0" spid="398" grpId="1"/>
     </p:bldLst>
   </p:timing>
 </p:sld>
@@ -15269,9 +15112,9 @@
       </p:par>
     </p:tnLst>
     <p:bldLst>
+      <p:bldP build="whole" bldLvl="1" animBg="1" rev="0" advAuto="0" spid="340" grpId="1"/>
+      <p:bldP build="p" bldLvl="5" animBg="1" rev="0" advAuto="0" spid="341" grpId="2"/>
       <p:bldP build="whole" bldLvl="1" animBg="1" rev="0" advAuto="0" spid="342" grpId="3"/>
-      <p:bldP build="p" bldLvl="5" animBg="1" rev="0" advAuto="0" spid="341" grpId="2"/>
-      <p:bldP build="whole" bldLvl="1" animBg="1" rev="0" advAuto="0" spid="340" grpId="1"/>
     </p:bldLst>
   </p:timing>
 </p:sld>
@@ -15674,8 +15517,8 @@
       </p:par>
     </p:tnLst>
     <p:bldLst>
+      <p:bldP build="whole" bldLvl="1" animBg="1" rev="0" advAuto="0" spid="346" grpId="2"/>
       <p:bldP build="p" bldLvl="5" animBg="1" rev="0" advAuto="0" spid="345" grpId="1"/>
-      <p:bldP build="whole" bldLvl="1" animBg="1" rev="0" advAuto="0" spid="346" grpId="2"/>
     </p:bldLst>
   </p:timing>
 </p:sld>
@@ -16356,9 +16199,9 @@
       </p:par>
     </p:tnLst>
     <p:bldLst>
-      <p:bldP build="whole" bldLvl="1" animBg="1" rev="0" advAuto="0" spid="357" grpId="3"/>
       <p:bldP build="whole" bldLvl="1" animBg="1" rev="0" advAuto="0" spid="351" grpId="1"/>
       <p:bldP build="whole" bldLvl="1" animBg="1" rev="0" advAuto="0" spid="354" grpId="2"/>
+      <p:bldP build="whole" bldLvl="1" animBg="1" rev="0" advAuto="0" spid="357" grpId="3"/>
     </p:bldLst>
   </p:timing>
 </p:sld>
@@ -16672,10 +16515,10 @@
                 <a:cs typeface="+mn-cs"/>
                 <a:sym typeface="Montserrat Thin Bold"/>
               </a:rPr>
-              <a:t>nije jedinstven</a:t>
-            </a:r>
-            <a:r>
-              <a:t> — može postojati više različitih</a:t>
+              <a:t>nije jedinstven </a:t>
+            </a:r>
+            <a:r>
+              <a:t>- može postojati više različitih</a:t>
             </a:r>
           </a:p>
           <a:p>
@@ -16743,7 +16586,7 @@
               <a:buChar char="⏵"/>
             </a:pPr>
             <a:r>
-              <a:t>Ne menja strukturu grafa — koristi se kao </a:t>
+              <a:t>Ne menja strukturu grafa - koristi se kao </a:t>
             </a:r>
             <a:r>
               <a:rPr>
@@ -17411,8 +17254,8 @@
       </p:par>
     </p:tnLst>
     <p:bldLst>
+      <p:bldP build="p" bldLvl="5" animBg="1" rev="0" advAuto="0" spid="360" grpId="1"/>
       <p:bldP build="whole" bldLvl="1" animBg="1" rev="0" advAuto="0" spid="361" grpId="2"/>
-      <p:bldP build="p" bldLvl="5" animBg="1" rev="0" advAuto="0" spid="360" grpId="1"/>
     </p:bldLst>
   </p:timing>
 </p:sld>
@@ -18266,7 +18109,7 @@
         <p:spPr>
           <a:xfrm>
             <a:off x="2032000" y="6941056"/>
-            <a:ext cx="15935059" cy="2210843"/>
+            <a:ext cx="17230062" cy="2210843"/>
           </a:xfrm>
           <a:prstGeom prst="rect">
             <a:avLst/>
@@ -18469,7 +18312,43 @@
                     </a:solidFill>
                     <a:latin typeface="Cambria Math" panose="02040503050406030204" pitchFamily="18" charset="0"/>
                   </a:rPr>
+                  <m:t>(</m:t>
+                </m:r>
+                <m:r>
+                  <a:rPr xmlns:a="http://schemas.openxmlformats.org/drawingml/2006/main" sz="3650" i="1">
+                    <a:solidFill>
+                      <a:srgbClr val="000000"/>
+                    </a:solidFill>
+                    <a:latin typeface="Cambria Math" panose="02040503050406030204" pitchFamily="18" charset="0"/>
+                  </a:rPr>
                   <m:t>V</m:t>
+                </m:r>
+                <m:r>
+                  <a:rPr xmlns:a="http://schemas.openxmlformats.org/drawingml/2006/main" sz="3650" i="1">
+                    <a:solidFill>
+                      <a:srgbClr val="000000"/>
+                    </a:solidFill>
+                    <a:latin typeface="Cambria Math" panose="02040503050406030204" pitchFamily="18" charset="0"/>
+                  </a:rPr>
+                  <m:t>+</m:t>
+                </m:r>
+                <m:r>
+                  <a:rPr xmlns:a="http://schemas.openxmlformats.org/drawingml/2006/main" sz="3650" i="1">
+                    <a:solidFill>
+                      <a:srgbClr val="000000"/>
+                    </a:solidFill>
+                    <a:latin typeface="Cambria Math" panose="02040503050406030204" pitchFamily="18" charset="0"/>
+                  </a:rPr>
+                  <m:t>E</m:t>
+                </m:r>
+                <m:r>
+                  <a:rPr xmlns:a="http://schemas.openxmlformats.org/drawingml/2006/main" sz="3650" i="1">
+                    <a:solidFill>
+                      <a:srgbClr val="000000"/>
+                    </a:solidFill>
+                    <a:latin typeface="Cambria Math" panose="02040503050406030204" pitchFamily="18" charset="0"/>
+                  </a:rPr>
+                  <m:t>)</m:t>
                 </m:r>
                 <m:r>
                   <a:rPr xmlns:a="http://schemas.openxmlformats.org/drawingml/2006/main" sz="3650" i="1">
@@ -19068,9 +18947,9 @@
       </p:par>
     </p:tnLst>
     <p:bldLst>
-      <p:bldP build="whole" bldLvl="1" animBg="1" rev="0" advAuto="0" spid="370" grpId="2"/>
       <p:bldP build="p" bldLvl="5" animBg="1" rev="0" advAuto="0" spid="369" grpId="3"/>
       <p:bldP build="p" bldLvl="5" animBg="1" rev="0" advAuto="0" spid="368" grpId="1"/>
+      <p:bldP build="whole" bldLvl="1" animBg="1" rev="0" advAuto="0" spid="370" grpId="2"/>
     </p:bldLst>
   </p:timing>
 </p:sld>

</xml_diff>